<commit_message>
fix(sesion-09): visual headless con --headed y materiales S9/S10
Los tests visuales capturan siempre en headless para coincidir con las baselines mientras el smoke acepta --headed. Incluye slides de anatomia del repo, PPT regeneradas y READMEs actualizados.

Co-authored-by: Cursor <cursoragent@cursor.com>
</commit_message>
<xml_diff>
--- a/sesiones/sesion-09/sesion-09.pptx
+++ b/sesiones/sesion-09/sesion-09.pptx
@@ -29,6 +29,7 @@
     <p:sldId id="277" r:id="rId28"/>
     <p:sldId id="278" r:id="rId29"/>
     <p:sldId id="279" r:id="rId30"/>
+    <p:sldId id="280" r:id="rId31"/>
   </p:sldIdLst>
   <p:sldSz cx="12191695" cy="6858000" type="screen4x3"/>
   <p:notesSz cx="6858000" cy="9144000"/>
@@ -3920,7 +3921,7 @@
                 </a:solidFill>
                 <a:latin typeface="Calibri"/>
               </a:rPr>
-              <a:t>Viewport 390×844</a:t>
+              <a:t>Qué archivo hace qué (sin curso de front)</a:t>
             </a:r>
           </a:p>
         </p:txBody>
@@ -3954,7 +3955,7 @@
                 </a:solidFill>
                 <a:latin typeface="Calibri"/>
               </a:rPr>
-              <a:t>Sesión 9 · Móvil y Regresión Visual · Slide 12</a:t>
+              <a:t>Sesión 9 · Móvil y Regresión Visual · Slide 11b</a:t>
             </a:r>
           </a:p>
         </p:txBody>
@@ -3993,55 +3994,87 @@
                 </a:solidFill>
                 <a:latin typeface="Calibri"/>
               </a:rPr>
-              <a:t>• Comando: uv run pytest tests/test_mobile_smoke.py -v</a:t>
-            </a:r>
-          </a:p>
-          <a:p>
-            <a:pPr>
-              <a:spcAft>
-                <a:spcPts val="1000"/>
-              </a:spcAft>
-            </a:pPr>
-            <a:r>
-              <a:rPr sz="1800" b="0">
-                <a:solidFill>
-                  <a:srgbClr val="2C3E50"/>
-                </a:solidFill>
-                <a:latin typeface="Calibri"/>
-              </a:rPr>
-              <a:t>• Login y “Agregar al carrito” usables en pantalla angosta</a:t>
-            </a:r>
-          </a:p>
-          <a:p>
-            <a:pPr>
-              <a:spcAft>
-                <a:spcPts val="1000"/>
-              </a:spcAft>
-            </a:pPr>
-            <a:r>
-              <a:rPr sz="1800" b="0">
-                <a:solidFill>
-                  <a:srgbClr val="2C3E50"/>
-                </a:solidFill>
-                <a:latin typeface="Calibri"/>
-              </a:rPr>
-              <a:t>• Selectores por rol + texto (lección S8)</a:t>
-            </a:r>
-          </a:p>
-          <a:p>
-            <a:pPr>
-              <a:spcAft>
-                <a:spcPts val="1000"/>
-              </a:spcAft>
-            </a:pPr>
-            <a:r>
-              <a:rPr sz="1800" b="0">
-                <a:solidFill>
-                  <a:srgbClr val="2C3E50"/>
-                </a:solidFill>
-                <a:latin typeface="Calibri"/>
-              </a:rPr>
-              <a:t>• Esperado: 2 passed</a:t>
+              <a:t>• pyproject.toml — deps (playwright, pillow) + testpaths = ["tests"]</a:t>
+            </a:r>
+          </a:p>
+          <a:p>
+            <a:pPr>
+              <a:spcAft>
+                <a:spcPts val="1000"/>
+              </a:spcAft>
+            </a:pPr>
+            <a:r>
+              <a:rPr sz="1800" b="0">
+                <a:solidFill>
+                  <a:srgbClr val="2C3E50"/>
+                </a:solidFill>
+                <a:latin typeface="Calibri"/>
+              </a:rPr>
+              <a:t>• tests/conftest.py — viewports 390×844 / 1280×720 + URLs file://</a:t>
+            </a:r>
+          </a:p>
+          <a:p>
+            <a:pPr>
+              <a:spcAft>
+                <a:spcPts val="1000"/>
+              </a:spcAft>
+            </a:pPr>
+            <a:r>
+              <a:rPr sz="1800" b="0">
+                <a:solidFill>
+                  <a:srgbClr val="2C3E50"/>
+                </a:solidFill>
+                <a:latin typeface="Calibri"/>
+              </a:rPr>
+              <a:t>• tests/baselines/*.png — contrato visual versionado en git</a:t>
+            </a:r>
+          </a:p>
+          <a:p>
+            <a:pPr>
+              <a:spcAft>
+                <a:spcPts val="1000"/>
+              </a:spcAft>
+            </a:pPr>
+            <a:r>
+              <a:rPr sz="1800" b="0">
+                <a:solidFill>
+                  <a:srgbClr val="2C3E50"/>
+                </a:solidFill>
+                <a:latin typeface="Calibri"/>
+              </a:rPr>
+              <a:t>• gate/ — suite roja aparte (mismo patrón que healing/ en S8)</a:t>
+            </a:r>
+          </a:p>
+          <a:p>
+            <a:pPr>
+              <a:spcAft>
+                <a:spcPts val="1000"/>
+              </a:spcAft>
+            </a:pPr>
+            <a:r>
+              <a:rPr sz="1800" b="0">
+                <a:solidFill>
+                  <a:srgbClr val="2C3E50"/>
+                </a:solidFill>
+                <a:latin typeface="Calibri"/>
+              </a:rPr>
+              <a:t>• reports/ — capturas actuales (gitignored)</a:t>
+            </a:r>
+          </a:p>
+          <a:p>
+            <a:pPr>
+              <a:spcAft>
+                <a:spcPts val="1000"/>
+              </a:spcAft>
+            </a:pPr>
+            <a:r>
+              <a:rPr sz="1800" b="0">
+                <a:solidFill>
+                  <a:srgbClr val="2C3E50"/>
+                </a:solidFill>
+                <a:latin typeface="Calibri"/>
+              </a:rPr>
+              <a:t>• app/index.html — solo importan ?broken=1 y ?theme=dark para los tests</a:t>
             </a:r>
           </a:p>
         </p:txBody>
@@ -4171,7 +4204,7 @@
                 </a:solidFill>
                 <a:latin typeface="Calibri"/>
               </a:rPr>
-              <a:t>El PNG que defiende el diseño</a:t>
+              <a:t>Viewport 390×844</a:t>
             </a:r>
           </a:p>
         </p:txBody>
@@ -4205,7 +4238,7 @@
                 </a:solidFill>
                 <a:latin typeface="Calibri"/>
               </a:rPr>
-              <a:t>Sesión 9 · Móvil y Regresión Visual · Slide 13</a:t>
+              <a:t>Sesión 9 · Móvil y Regresión Visual · Slide 12</a:t>
             </a:r>
           </a:p>
         </p:txBody>
@@ -4244,55 +4277,55 @@
                 </a:solidFill>
                 <a:latin typeface="Calibri"/>
               </a:rPr>
-              <a:t>• tests/baselines/home-desktop-light.png (y dark / mobile)</a:t>
-            </a:r>
-          </a:p>
-          <a:p>
-            <a:pPr>
-              <a:spcAft>
-                <a:spcPts val="1000"/>
-              </a:spcAft>
-            </a:pPr>
-            <a:r>
-              <a:rPr sz="1800" b="0">
-                <a:solidFill>
-                  <a:srgbClr val="2C3E50"/>
-                </a:solidFill>
-                <a:latin typeface="Calibri"/>
-              </a:rPr>
-              <a:t>• Se versionan en git: son el contrato visual</a:t>
-            </a:r>
-          </a:p>
-          <a:p>
-            <a:pPr>
-              <a:spcAft>
-                <a:spcPts val="1000"/>
-              </a:spcAft>
-            </a:pPr>
-            <a:r>
-              <a:rPr sz="1800" b="0">
-                <a:solidFill>
-                  <a:srgbClr val="2C3E50"/>
-                </a:solidFill>
-                <a:latin typeface="Calibri"/>
-              </a:rPr>
-              <a:t>• Regenerar solo tras cambio intencional de UI</a:t>
-            </a:r>
-          </a:p>
-          <a:p>
-            <a:pPr>
-              <a:spcAft>
-                <a:spcPts val="1000"/>
-              </a:spcAft>
-            </a:pPr>
-            <a:r>
-              <a:rPr sz="1800" b="0">
-                <a:solidFill>
-                  <a:srgbClr val="2C3E50"/>
-                </a:solidFill>
-                <a:latin typeface="Calibri"/>
-              </a:rPr>
-              <a:t>• Script: uv run python scripts/capture_baselines.py</a:t>
+              <a:t>• Comando: uv run pytest tests/test_mobile_smoke.py -v</a:t>
+            </a:r>
+          </a:p>
+          <a:p>
+            <a:pPr>
+              <a:spcAft>
+                <a:spcPts val="1000"/>
+              </a:spcAft>
+            </a:pPr>
+            <a:r>
+              <a:rPr sz="1800" b="0">
+                <a:solidFill>
+                  <a:srgbClr val="2C3E50"/>
+                </a:solidFill>
+                <a:latin typeface="Calibri"/>
+              </a:rPr>
+              <a:t>• Login y “Agregar al carrito” usables en pantalla angosta</a:t>
+            </a:r>
+          </a:p>
+          <a:p>
+            <a:pPr>
+              <a:spcAft>
+                <a:spcPts val="1000"/>
+              </a:spcAft>
+            </a:pPr>
+            <a:r>
+              <a:rPr sz="1800" b="0">
+                <a:solidFill>
+                  <a:srgbClr val="2C3E50"/>
+                </a:solidFill>
+                <a:latin typeface="Calibri"/>
+              </a:rPr>
+              <a:t>• Selectores por rol + texto (lección S8)</a:t>
+            </a:r>
+          </a:p>
+          <a:p>
+            <a:pPr>
+              <a:spcAft>
+                <a:spcPts val="1000"/>
+              </a:spcAft>
+            </a:pPr>
+            <a:r>
+              <a:rPr sz="1800" b="0">
+                <a:solidFill>
+                  <a:srgbClr val="2C3E50"/>
+                </a:solidFill>
+                <a:latin typeface="Calibri"/>
+              </a:rPr>
+              <a:t>• Esperado: 2 passed</a:t>
             </a:r>
           </a:p>
         </p:txBody>
@@ -4422,7 +4455,7 @@
                 </a:solidFill>
                 <a:latin typeface="Calibri"/>
               </a:rPr>
-              <a:t>Diff ≤ 120 píxeles</a:t>
+              <a:t>El PNG que defiende el diseño</a:t>
             </a:r>
           </a:p>
         </p:txBody>
@@ -4456,7 +4489,7 @@
                 </a:solidFill>
                 <a:latin typeface="Calibri"/>
               </a:rPr>
-              <a:t>Sesión 9 · Móvil y Regresión Visual · Slide 14</a:t>
+              <a:t>Sesión 9 · Móvil y Regresión Visual · Slide 13</a:t>
             </a:r>
           </a:p>
         </p:txBody>
@@ -4495,55 +4528,55 @@
                 </a:solidFill>
                 <a:latin typeface="Calibri"/>
               </a:rPr>
-              <a:t>• Comando: uv run pytest tests/test_visual_regression.py -v</a:t>
-            </a:r>
-          </a:p>
-          <a:p>
-            <a:pPr>
-              <a:spcAft>
-                <a:spcPts val="1000"/>
-              </a:spcAft>
-            </a:pPr>
-            <a:r>
-              <a:rPr sz="1800" b="0">
-                <a:solidFill>
-                  <a:srgbClr val="2C3E50"/>
-                </a:solidFill>
-                <a:latin typeface="Calibri"/>
-              </a:rPr>
-              <a:t>• Tres casos: desktop light · desktop dark · mobile light</a:t>
-            </a:r>
-          </a:p>
-          <a:p>
-            <a:pPr>
-              <a:spcAft>
-                <a:spcPts val="1000"/>
-              </a:spcAft>
-            </a:pPr>
-            <a:r>
-              <a:rPr sz="1800" b="0">
-                <a:solidFill>
-                  <a:srgbClr val="2C3E50"/>
-                </a:solidFill>
-                <a:latin typeface="Calibri"/>
-              </a:rPr>
-              <a:t>• Umbral pequeño tolera anti-aliasing entre máquinas</a:t>
-            </a:r>
-          </a:p>
-          <a:p>
-            <a:pPr>
-              <a:spcAft>
-                <a:spcPts val="1000"/>
-              </a:spcAft>
-            </a:pPr>
-            <a:r>
-              <a:rPr sz="1800" b="0">
-                <a:solidFill>
-                  <a:srgbClr val="2C3E50"/>
-                </a:solidFill>
-                <a:latin typeface="Calibri"/>
-              </a:rPr>
-              <a:t>• Esperado: 3 passed</a:t>
+              <a:t>• tests/baselines/home-desktop-light.png (y dark / mobile)</a:t>
+            </a:r>
+          </a:p>
+          <a:p>
+            <a:pPr>
+              <a:spcAft>
+                <a:spcPts val="1000"/>
+              </a:spcAft>
+            </a:pPr>
+            <a:r>
+              <a:rPr sz="1800" b="0">
+                <a:solidFill>
+                  <a:srgbClr val="2C3E50"/>
+                </a:solidFill>
+                <a:latin typeface="Calibri"/>
+              </a:rPr>
+              <a:t>• Se versionan en git: son el contrato visual</a:t>
+            </a:r>
+          </a:p>
+          <a:p>
+            <a:pPr>
+              <a:spcAft>
+                <a:spcPts val="1000"/>
+              </a:spcAft>
+            </a:pPr>
+            <a:r>
+              <a:rPr sz="1800" b="0">
+                <a:solidFill>
+                  <a:srgbClr val="2C3E50"/>
+                </a:solidFill>
+                <a:latin typeface="Calibri"/>
+              </a:rPr>
+              <a:t>• Regenerar solo tras cambio intencional de UI</a:t>
+            </a:r>
+          </a:p>
+          <a:p>
+            <a:pPr>
+              <a:spcAft>
+                <a:spcPts val="1000"/>
+              </a:spcAft>
+            </a:pPr>
+            <a:r>
+              <a:rPr sz="1800" b="0">
+                <a:solidFill>
+                  <a:srgbClr val="2C3E50"/>
+                </a:solidFill>
+                <a:latin typeface="Calibri"/>
+              </a:rPr>
+              <a:t>• Script: uv run python scripts/capture_baselines.py</a:t>
             </a:r>
           </a:p>
         </p:txBody>
@@ -4673,7 +4706,7 @@
                 </a:solidFill>
                 <a:latin typeface="Calibri"/>
               </a:rPr>
-              <a:t>5 passed</a:t>
+              <a:t>Diff ≤ 120 píxeles</a:t>
             </a:r>
           </a:p>
         </p:txBody>
@@ -4707,7 +4740,7 @@
                 </a:solidFill>
                 <a:latin typeface="Calibri"/>
               </a:rPr>
-              <a:t>Sesión 9 · Móvil y Regresión Visual · Slide 15</a:t>
+              <a:t>Sesión 9 · Móvil y Regresión Visual · Slide 14</a:t>
             </a:r>
           </a:p>
         </p:txBody>
@@ -4746,55 +4779,55 @@
                 </a:solidFill>
                 <a:latin typeface="Calibri"/>
               </a:rPr>
-              <a:t>• Comando: uv run pytest tests -v</a:t>
-            </a:r>
-          </a:p>
-          <a:p>
-            <a:pPr>
-              <a:spcAft>
-                <a:spcPts val="1000"/>
-              </a:spcAft>
-            </a:pPr>
-            <a:r>
-              <a:rPr sz="1800" b="0">
-                <a:solidFill>
-                  <a:srgbClr val="2C3E50"/>
-                </a:solidFill>
-                <a:latin typeface="Calibri"/>
-              </a:rPr>
-              <a:t>• Smoke (2) + visual (3) = suite verde del lab</a:t>
-            </a:r>
-          </a:p>
-          <a:p>
-            <a:pPr>
-              <a:spcAft>
-                <a:spcPts val="1000"/>
-              </a:spcAft>
-            </a:pPr>
-            <a:r>
-              <a:rPr sz="1800" b="0">
-                <a:solidFill>
-                  <a:srgbClr val="2C3E50"/>
-                </a:solidFill>
-                <a:latin typeface="Calibri"/>
-              </a:rPr>
-              <a:t>• Task: task test:mobile</a:t>
-            </a:r>
-          </a:p>
-          <a:p>
-            <a:pPr>
-              <a:spcAft>
-                <a:spcPts val="1000"/>
-              </a:spcAft>
-            </a:pPr>
-            <a:r>
-              <a:rPr sz="1800" b="0">
-                <a:solidFill>
-                  <a:srgbClr val="2C3E50"/>
-                </a:solidFill>
-                <a:latin typeface="Calibri"/>
-              </a:rPr>
-              <a:t>• El gate rojo va aparte (siguiente slide)</a:t>
+              <a:t>• Comando: uv run pytest tests/test_visual_regression.py -v</a:t>
+            </a:r>
+          </a:p>
+          <a:p>
+            <a:pPr>
+              <a:spcAft>
+                <a:spcPts val="1000"/>
+              </a:spcAft>
+            </a:pPr>
+            <a:r>
+              <a:rPr sz="1800" b="0">
+                <a:solidFill>
+                  <a:srgbClr val="2C3E50"/>
+                </a:solidFill>
+                <a:latin typeface="Calibri"/>
+              </a:rPr>
+              <a:t>• Tres casos: desktop light · desktop dark · mobile light</a:t>
+            </a:r>
+          </a:p>
+          <a:p>
+            <a:pPr>
+              <a:spcAft>
+                <a:spcPts val="1000"/>
+              </a:spcAft>
+            </a:pPr>
+            <a:r>
+              <a:rPr sz="1800" b="0">
+                <a:solidFill>
+                  <a:srgbClr val="2C3E50"/>
+                </a:solidFill>
+                <a:latin typeface="Calibri"/>
+              </a:rPr>
+              <a:t>• Umbral pequeño tolera anti-aliasing entre máquinas</a:t>
+            </a:r>
+          </a:p>
+          <a:p>
+            <a:pPr>
+              <a:spcAft>
+                <a:spcPts val="1000"/>
+              </a:spcAft>
+            </a:pPr>
+            <a:r>
+              <a:rPr sz="1800" b="0">
+                <a:solidFill>
+                  <a:srgbClr val="2C3E50"/>
+                </a:solidFill>
+                <a:latin typeface="Calibri"/>
+              </a:rPr>
+              <a:t>• Esperado: 3 passed</a:t>
             </a:r>
           </a:p>
         </p:txBody>
@@ -4924,7 +4957,7 @@
                 </a:solidFill>
                 <a:latin typeface="Calibri"/>
               </a:rPr>
-              <a:t>broken=1 debe tumbar el build</a:t>
+              <a:t>5 passed</a:t>
             </a:r>
           </a:p>
         </p:txBody>
@@ -4958,7 +4991,7 @@
                 </a:solidFill>
                 <a:latin typeface="Calibri"/>
               </a:rPr>
-              <a:t>Sesión 9 · Móvil y Regresión Visual · Slide 16</a:t>
+              <a:t>Sesión 9 · Móvil y Regresión Visual · Slide 15</a:t>
             </a:r>
           </a:p>
         </p:txBody>
@@ -4997,55 +5030,55 @@
                 </a:solidFill>
                 <a:latin typeface="Calibri"/>
               </a:rPr>
-              <a:t>• Comando: uv run pytest gate -v</a:t>
-            </a:r>
-          </a:p>
-          <a:p>
-            <a:pPr>
-              <a:spcAft>
-                <a:spcPts val="1000"/>
-              </a:spcAft>
-            </a:pPr>
-            <a:r>
-              <a:rPr sz="1800" b="0">
-                <a:solidFill>
-                  <a:srgbClr val="2C3E50"/>
-                </a:solidFill>
-                <a:latin typeface="Calibri"/>
-              </a:rPr>
-              <a:t>• ?broken=1 mete banner rojo y cambia el precio</a:t>
-            </a:r>
-          </a:p>
-          <a:p>
-            <a:pPr>
-              <a:spcAft>
-                <a:spcPts val="1000"/>
-              </a:spcAft>
-            </a:pPr>
-            <a:r>
-              <a:rPr sz="1800" b="0">
-                <a:solidFill>
-                  <a:srgbClr val="2C3E50"/>
-                </a:solidFill>
-                <a:latin typeface="Calibri"/>
-              </a:rPr>
-              <a:t>• Compara contra baseline sana → FAILED · exit 1</a:t>
-            </a:r>
-          </a:p>
-          <a:p>
-            <a:pPr>
-              <a:spcAft>
-                <a:spcPts val="1000"/>
-              </a:spcAft>
-            </a:pPr>
-            <a:r>
-              <a:rPr sz="1800" b="0">
-                <a:solidFill>
-                  <a:srgbClr val="2C3E50"/>
-                </a:solidFill>
-                <a:latin typeface="Calibri"/>
-              </a:rPr>
-              <a:t>• Misma lección que Axe: si hay fallo, no maquilles el verde</a:t>
+              <a:t>• Comando: uv run pytest tests -v</a:t>
+            </a:r>
+          </a:p>
+          <a:p>
+            <a:pPr>
+              <a:spcAft>
+                <a:spcPts val="1000"/>
+              </a:spcAft>
+            </a:pPr>
+            <a:r>
+              <a:rPr sz="1800" b="0">
+                <a:solidFill>
+                  <a:srgbClr val="2C3E50"/>
+                </a:solidFill>
+                <a:latin typeface="Calibri"/>
+              </a:rPr>
+              <a:t>• Smoke (2) + visual (3) = suite verde del lab</a:t>
+            </a:r>
+          </a:p>
+          <a:p>
+            <a:pPr>
+              <a:spcAft>
+                <a:spcPts val="1000"/>
+              </a:spcAft>
+            </a:pPr>
+            <a:r>
+              <a:rPr sz="1800" b="0">
+                <a:solidFill>
+                  <a:srgbClr val="2C3E50"/>
+                </a:solidFill>
+                <a:latin typeface="Calibri"/>
+              </a:rPr>
+              <a:t>• Task: task test:mobile</a:t>
+            </a:r>
+          </a:p>
+          <a:p>
+            <a:pPr>
+              <a:spcAft>
+                <a:spcPts val="1000"/>
+              </a:spcAft>
+            </a:pPr>
+            <a:r>
+              <a:rPr sz="1800" b="0">
+                <a:solidFill>
+                  <a:srgbClr val="2C3E50"/>
+                </a:solidFill>
+                <a:latin typeface="Calibri"/>
+              </a:rPr>
+              <a:t>• El gate rojo va aparte (siguiente slide)</a:t>
             </a:r>
           </a:p>
         </p:txBody>
@@ -5175,7 +5208,7 @@
                 </a:solidFill>
                 <a:latin typeface="Calibri"/>
               </a:rPr>
-              <a:t>Plantilla qa-visual.yml</a:t>
+              <a:t>broken=1 debe tumbar el build</a:t>
             </a:r>
           </a:p>
         </p:txBody>
@@ -5209,7 +5242,7 @@
                 </a:solidFill>
                 <a:latin typeface="Calibri"/>
               </a:rPr>
-              <a:t>Sesión 9 · Móvil y Regresión Visual · Slide 17</a:t>
+              <a:t>Sesión 9 · Móvil y Regresión Visual · Slide 16</a:t>
             </a:r>
           </a:p>
         </p:txBody>
@@ -5248,55 +5281,55 @@
                 </a:solidFill>
                 <a:latin typeface="Calibri"/>
               </a:rPr>
-              <a:t>• Mismo smoke + visual en GitHub Actions</a:t>
-            </a:r>
-          </a:p>
-          <a:p>
-            <a:pPr>
-              <a:spcAft>
-                <a:spcPts val="1000"/>
-              </a:spcAft>
-            </a:pPr>
-            <a:r>
-              <a:rPr sz="1800" b="0">
-                <a:solidFill>
-                  <a:srgbClr val="2C3E50"/>
-                </a:solidFill>
-                <a:latin typeface="Calibri"/>
-              </a:rPr>
-              <a:t>• Gate: espera exit 1 del demo roto (prueba que el umbral vive)</a:t>
-            </a:r>
-          </a:p>
-          <a:p>
-            <a:pPr>
-              <a:spcAft>
-                <a:spcPts val="1000"/>
-              </a:spcAft>
-            </a:pPr>
-            <a:r>
-              <a:rPr sz="1800" b="0">
-                <a:solidFill>
-                  <a:srgbClr val="2C3E50"/>
-                </a:solidFill>
-                <a:latin typeface="Calibri"/>
-              </a:rPr>
-              <a:t>• Artefacto: capturas en reports/</a:t>
-            </a:r>
-          </a:p>
-          <a:p>
-            <a:pPr>
-              <a:spcAft>
-                <a:spcPts val="1000"/>
-              </a:spcAft>
-            </a:pPr>
-            <a:r>
-              <a:rPr sz="1800" b="0">
-                <a:solidFill>
-                  <a:srgbClr val="2C3E50"/>
-                </a:solidFill>
-                <a:latin typeface="Calibri"/>
-              </a:rPr>
-              <a:t>• Logro B: mediste layout, no solo clicks</a:t>
+              <a:t>• Comando: uv run pytest gate -v</a:t>
+            </a:r>
+          </a:p>
+          <a:p>
+            <a:pPr>
+              <a:spcAft>
+                <a:spcPts val="1000"/>
+              </a:spcAft>
+            </a:pPr>
+            <a:r>
+              <a:rPr sz="1800" b="0">
+                <a:solidFill>
+                  <a:srgbClr val="2C3E50"/>
+                </a:solidFill>
+                <a:latin typeface="Calibri"/>
+              </a:rPr>
+              <a:t>• ?broken=1 mete banner rojo y cambia el precio</a:t>
+            </a:r>
+          </a:p>
+          <a:p>
+            <a:pPr>
+              <a:spcAft>
+                <a:spcPts val="1000"/>
+              </a:spcAft>
+            </a:pPr>
+            <a:r>
+              <a:rPr sz="1800" b="0">
+                <a:solidFill>
+                  <a:srgbClr val="2C3E50"/>
+                </a:solidFill>
+                <a:latin typeface="Calibri"/>
+              </a:rPr>
+              <a:t>• Compara contra baseline sana → FAILED · exit 1</a:t>
+            </a:r>
+          </a:p>
+          <a:p>
+            <a:pPr>
+              <a:spcAft>
+                <a:spcPts val="1000"/>
+              </a:spcAft>
+            </a:pPr>
+            <a:r>
+              <a:rPr sz="1800" b="0">
+                <a:solidFill>
+                  <a:srgbClr val="2C3E50"/>
+                </a:solidFill>
+                <a:latin typeface="Calibri"/>
+              </a:rPr>
+              <a:t>• Misma lección que Axe: si hay fallo, no maquilles el verde</a:t>
             </a:r>
           </a:p>
         </p:txBody>
@@ -5426,7 +5459,7 @@
                 </a:solidFill>
                 <a:latin typeface="Calibri"/>
               </a:rPr>
-              <a:t>Dark, responsive y el mapa IA</a:t>
+              <a:t>Plantilla qa-visual.yml</a:t>
             </a:r>
           </a:p>
         </p:txBody>
@@ -5460,7 +5493,7 @@
                 </a:solidFill>
                 <a:latin typeface="Calibri"/>
               </a:rPr>
-              <a:t>Sesión 9 · Móvil y Regresión Visual · Slide 18</a:t>
+              <a:t>Sesión 9 · Móvil y Regresión Visual · Slide 17</a:t>
             </a:r>
           </a:p>
         </p:txBody>
@@ -5499,39 +5532,55 @@
                 </a:solidFill>
                 <a:latin typeface="Calibri"/>
               </a:rPr>
-              <a:t>• Ya tenés verde + rojo del gate</a:t>
-            </a:r>
-          </a:p>
-          <a:p>
-            <a:pPr>
-              <a:spcAft>
-                <a:spcPts val="1000"/>
-              </a:spcAft>
-            </a:pPr>
-            <a:r>
-              <a:rPr sz="1800" b="0">
-                <a:solidFill>
-                  <a:srgbClr val="2C3E50"/>
-                </a:solidFill>
-                <a:latin typeface="Calibri"/>
-              </a:rPr>
-              <a:t>• Ahora: modo oscuro, breakpoints, cuándo pagar Applitools/Percy</a:t>
-            </a:r>
-          </a:p>
-          <a:p>
-            <a:pPr>
-              <a:spcAft>
-                <a:spcPts val="1000"/>
-              </a:spcAft>
-            </a:pPr>
-            <a:r>
-              <a:rPr sz="1800" b="0">
-                <a:solidFill>
-                  <a:srgbClr val="2C3E50"/>
-                </a:solidFill>
-                <a:latin typeface="Calibri"/>
-              </a:rPr>
-              <a:t>• Cierre: Etapa 9 + puente a S10</a:t>
+              <a:t>• Mismo smoke + visual en GitHub Actions</a:t>
+            </a:r>
+          </a:p>
+          <a:p>
+            <a:pPr>
+              <a:spcAft>
+                <a:spcPts val="1000"/>
+              </a:spcAft>
+            </a:pPr>
+            <a:r>
+              <a:rPr sz="1800" b="0">
+                <a:solidFill>
+                  <a:srgbClr val="2C3E50"/>
+                </a:solidFill>
+                <a:latin typeface="Calibri"/>
+              </a:rPr>
+              <a:t>• Gate: espera exit 1 del demo roto (prueba que el umbral vive)</a:t>
+            </a:r>
+          </a:p>
+          <a:p>
+            <a:pPr>
+              <a:spcAft>
+                <a:spcPts val="1000"/>
+              </a:spcAft>
+            </a:pPr>
+            <a:r>
+              <a:rPr sz="1800" b="0">
+                <a:solidFill>
+                  <a:srgbClr val="2C3E50"/>
+                </a:solidFill>
+                <a:latin typeface="Calibri"/>
+              </a:rPr>
+              <a:t>• Artefacto: capturas en reports/</a:t>
+            </a:r>
+          </a:p>
+          <a:p>
+            <a:pPr>
+              <a:spcAft>
+                <a:spcPts val="1000"/>
+              </a:spcAft>
+            </a:pPr>
+            <a:r>
+              <a:rPr sz="1800" b="0">
+                <a:solidFill>
+                  <a:srgbClr val="2C3E50"/>
+                </a:solidFill>
+                <a:latin typeface="Calibri"/>
+              </a:rPr>
+              <a:t>• Logro B: mediste layout, no solo clicks</a:t>
             </a:r>
           </a:p>
         </p:txBody>
@@ -5661,7 +5710,7 @@
                 </a:solidFill>
                 <a:latin typeface="Calibri"/>
               </a:rPr>
-              <a:t>prefers / data-theme</a:t>
+              <a:t>Dark, responsive y el mapa IA</a:t>
             </a:r>
           </a:p>
         </p:txBody>
@@ -5695,7 +5744,7 @@
                 </a:solidFill>
                 <a:latin typeface="Calibri"/>
               </a:rPr>
-              <a:t>Sesión 9 · Móvil y Regresión Visual · Slide 19</a:t>
+              <a:t>Sesión 9 · Móvil y Regresión Visual · Slide 18</a:t>
             </a:r>
           </a:p>
         </p:txBody>
@@ -5734,55 +5783,39 @@
                 </a:solidFill>
                 <a:latin typeface="Calibri"/>
               </a:rPr>
-              <a:t>• ?theme=dark fuerza la baseline oscura</a:t>
-            </a:r>
-          </a:p>
-          <a:p>
-            <a:pPr>
-              <a:spcAft>
-                <a:spcPts val="1000"/>
-              </a:spcAft>
-            </a:pPr>
-            <a:r>
-              <a:rPr sz="1800" b="0">
-                <a:solidFill>
-                  <a:srgbClr val="2C3E50"/>
-                </a:solidFill>
-                <a:latin typeface="Calibri"/>
-              </a:rPr>
-              <a:t>• El toggle “Modo oscuro” cambia data-theme en vivo</a:t>
-            </a:r>
-          </a:p>
-          <a:p>
-            <a:pPr>
-              <a:spcAft>
-                <a:spcPts val="1000"/>
-              </a:spcAft>
-            </a:pPr>
-            <a:r>
-              <a:rPr sz="1800" b="0">
-                <a:solidFill>
-                  <a:srgbClr val="2C3E50"/>
-                </a:solidFill>
-                <a:latin typeface="Calibri"/>
-              </a:rPr>
-              <a:t>• Una suite visual sin dark deja un hueco típico de regresión</a:t>
-            </a:r>
-          </a:p>
-          <a:p>
-            <a:pPr>
-              <a:spcAft>
-                <a:spcPts val="1000"/>
-              </a:spcAft>
-            </a:pPr>
-            <a:r>
-              <a:rPr sz="1800" b="0">
-                <a:solidFill>
-                  <a:srgbClr val="2C3E50"/>
-                </a:solidFill>
-                <a:latin typeface="Calibri"/>
-              </a:rPr>
-              <a:t>• Baseline: home-desktop-dark.png</a:t>
+              <a:t>• Ya tenés verde + rojo del gate</a:t>
+            </a:r>
+          </a:p>
+          <a:p>
+            <a:pPr>
+              <a:spcAft>
+                <a:spcPts val="1000"/>
+              </a:spcAft>
+            </a:pPr>
+            <a:r>
+              <a:rPr sz="1800" b="0">
+                <a:solidFill>
+                  <a:srgbClr val="2C3E50"/>
+                </a:solidFill>
+                <a:latin typeface="Calibri"/>
+              </a:rPr>
+              <a:t>• Ahora: modo oscuro, breakpoints, cuándo pagar Applitools/Percy</a:t>
+            </a:r>
+          </a:p>
+          <a:p>
+            <a:pPr>
+              <a:spcAft>
+                <a:spcPts val="1000"/>
+              </a:spcAft>
+            </a:pPr>
+            <a:r>
+              <a:rPr sz="1800" b="0">
+                <a:solidFill>
+                  <a:srgbClr val="2C3E50"/>
+                </a:solidFill>
+                <a:latin typeface="Calibri"/>
+              </a:rPr>
+              <a:t>• Cierre: Etapa 9 + puente a S10</a:t>
             </a:r>
           </a:p>
         </p:txBody>
@@ -6163,7 +6196,7 @@
                 </a:solidFill>
                 <a:latin typeface="Calibri"/>
               </a:rPr>
-              <a:t>Media query ≥ 768px</a:t>
+              <a:t>prefers / data-theme</a:t>
             </a:r>
           </a:p>
         </p:txBody>
@@ -6197,7 +6230,7 @@
                 </a:solidFill>
                 <a:latin typeface="Calibri"/>
               </a:rPr>
-              <a:t>Sesión 9 · Móvil y Regresión Visual · Slide 20</a:t>
+              <a:t>Sesión 9 · Móvil y Regresión Visual · Slide 19</a:t>
             </a:r>
           </a:p>
         </p:txBody>
@@ -6236,55 +6269,55 @@
                 </a:solidFill>
                 <a:latin typeface="Calibri"/>
               </a:rPr>
-              <a:t>• En móvil: una columna; en desktop: dos columnas</a:t>
-            </a:r>
-          </a:p>
-          <a:p>
-            <a:pPr>
-              <a:spcAft>
-                <a:spcPts val="1000"/>
-              </a:spcAft>
-            </a:pPr>
-            <a:r>
-              <a:rPr sz="1800" b="0">
-                <a:solidFill>
-                  <a:srgbClr val="2C3E50"/>
-                </a:solidFill>
-                <a:latin typeface="Calibri"/>
-              </a:rPr>
-              <a:t>• Abrí app/index.html y mirá el @media</a:t>
-            </a:r>
-          </a:p>
-          <a:p>
-            <a:pPr>
-              <a:spcAft>
-                <a:spcPts val="1000"/>
-              </a:spcAft>
-            </a:pPr>
-            <a:r>
-              <a:rPr sz="1800" b="0">
-                <a:solidFill>
-                  <a:srgbClr val="2C3E50"/>
-                </a:solidFill>
-                <a:latin typeface="Calibri"/>
-              </a:rPr>
-              <a:t>• El smoke móvil protege el camino crítico en angosto</a:t>
-            </a:r>
-          </a:p>
-          <a:p>
-            <a:pPr>
-              <a:spcAft>
-                <a:spcPts val="1000"/>
-              </a:spcAft>
-            </a:pPr>
-            <a:r>
-              <a:rPr sz="1800" b="0">
-                <a:solidFill>
-                  <a:srgbClr val="2C3E50"/>
-                </a:solidFill>
-                <a:latin typeface="Calibri"/>
-              </a:rPr>
-              <a:t>• Visual desktop protege el layout ancho</a:t>
+              <a:t>• ?theme=dark fuerza la baseline oscura</a:t>
+            </a:r>
+          </a:p>
+          <a:p>
+            <a:pPr>
+              <a:spcAft>
+                <a:spcPts val="1000"/>
+              </a:spcAft>
+            </a:pPr>
+            <a:r>
+              <a:rPr sz="1800" b="0">
+                <a:solidFill>
+                  <a:srgbClr val="2C3E50"/>
+                </a:solidFill>
+                <a:latin typeface="Calibri"/>
+              </a:rPr>
+              <a:t>• El toggle “Modo oscuro” cambia data-theme en vivo</a:t>
+            </a:r>
+          </a:p>
+          <a:p>
+            <a:pPr>
+              <a:spcAft>
+                <a:spcPts val="1000"/>
+              </a:spcAft>
+            </a:pPr>
+            <a:r>
+              <a:rPr sz="1800" b="0">
+                <a:solidFill>
+                  <a:srgbClr val="2C3E50"/>
+                </a:solidFill>
+                <a:latin typeface="Calibri"/>
+              </a:rPr>
+              <a:t>• Una suite visual sin dark deja un hueco típico de regresión</a:t>
+            </a:r>
+          </a:p>
+          <a:p>
+            <a:pPr>
+              <a:spcAft>
+                <a:spcPts val="1000"/>
+              </a:spcAft>
+            </a:pPr>
+            <a:r>
+              <a:rPr sz="1800" b="0">
+                <a:solidFill>
+                  <a:srgbClr val="2C3E50"/>
+                </a:solidFill>
+                <a:latin typeface="Calibri"/>
+              </a:rPr>
+              <a:t>• Baseline: home-desktop-dark.png</a:t>
             </a:r>
           </a:p>
         </p:txBody>
@@ -6414,7 +6447,7 @@
                 </a:solidFill>
                 <a:latin typeface="Calibri"/>
               </a:rPr>
-              <a:t>Cuándo el PNG local no alcanza</a:t>
+              <a:t>Media query ≥ 768px</a:t>
             </a:r>
           </a:p>
         </p:txBody>
@@ -6448,7 +6481,7 @@
                 </a:solidFill>
                 <a:latin typeface="Calibri"/>
               </a:rPr>
-              <a:t>Sesión 9 · Móvil y Regresión Visual · Slide 21</a:t>
+              <a:t>Sesión 9 · Móvil y Regresión Visual · Slide 20</a:t>
             </a:r>
           </a:p>
         </p:txBody>
@@ -6487,55 +6520,55 @@
                 </a:solidFill>
                 <a:latin typeface="Calibri"/>
               </a:rPr>
-              <a:t>• Applitools — IA visual, baselines cloud, caro y potente</a:t>
-            </a:r>
-          </a:p>
-          <a:p>
-            <a:pPr>
-              <a:spcAft>
-                <a:spcPts val="1000"/>
-              </a:spcAft>
-            </a:pPr>
-            <a:r>
-              <a:rPr sz="1800" b="0">
-                <a:solidFill>
-                  <a:srgbClr val="2C3E50"/>
-                </a:solidFill>
-                <a:latin typeface="Calibri"/>
-              </a:rPr>
-              <a:t>• Percy / Chromatic — revisiones visuales en el PR</a:t>
-            </a:r>
-          </a:p>
-          <a:p>
-            <a:pPr>
-              <a:spcAft>
-                <a:spcPts val="1000"/>
-              </a:spcAft>
-            </a:pPr>
-            <a:r>
-              <a:rPr sz="1800" b="0">
-                <a:solidFill>
-                  <a:srgbClr val="2C3E50"/>
-                </a:solidFill>
-                <a:latin typeface="Calibri"/>
-              </a:rPr>
-              <a:t>• PNG local: cero costo, control total, más mantenimiento manual</a:t>
-            </a:r>
-          </a:p>
-          <a:p>
-            <a:pPr>
-              <a:spcAft>
-                <a:spcPts val="1000"/>
-              </a:spcAft>
-            </a:pPr>
-            <a:r>
-              <a:rPr sz="1800" b="0">
-                <a:solidFill>
-                  <a:srgbClr val="2C3E50"/>
-                </a:solidFill>
-                <a:latin typeface="Calibri"/>
-              </a:rPr>
-              <a:t>• Regla: local para aprender; cloud cuando el equipo escala</a:t>
+              <a:t>• En móvil: una columna; en desktop: dos columnas</a:t>
+            </a:r>
+          </a:p>
+          <a:p>
+            <a:pPr>
+              <a:spcAft>
+                <a:spcPts val="1000"/>
+              </a:spcAft>
+            </a:pPr>
+            <a:r>
+              <a:rPr sz="1800" b="0">
+                <a:solidFill>
+                  <a:srgbClr val="2C3E50"/>
+                </a:solidFill>
+                <a:latin typeface="Calibri"/>
+              </a:rPr>
+              <a:t>• Abrí app/index.html y mirá el @media</a:t>
+            </a:r>
+          </a:p>
+          <a:p>
+            <a:pPr>
+              <a:spcAft>
+                <a:spcPts val="1000"/>
+              </a:spcAft>
+            </a:pPr>
+            <a:r>
+              <a:rPr sz="1800" b="0">
+                <a:solidFill>
+                  <a:srgbClr val="2C3E50"/>
+                </a:solidFill>
+                <a:latin typeface="Calibri"/>
+              </a:rPr>
+              <a:t>• El smoke móvil protege el camino crítico en angosto</a:t>
+            </a:r>
+          </a:p>
+          <a:p>
+            <a:pPr>
+              <a:spcAft>
+                <a:spcPts val="1000"/>
+              </a:spcAft>
+            </a:pPr>
+            <a:r>
+              <a:rPr sz="1800" b="0">
+                <a:solidFill>
+                  <a:srgbClr val="2C3E50"/>
+                </a:solidFill>
+                <a:latin typeface="Calibri"/>
+              </a:rPr>
+              <a:t>• Visual desktop protege el layout ancho</a:t>
             </a:r>
           </a:p>
         </p:txBody>
@@ -6665,7 +6698,7 @@
                 </a:solidFill>
                 <a:latin typeface="Calibri"/>
               </a:rPr>
-              <a:t>¿Te llevás esto?</a:t>
+              <a:t>Cuándo el PNG local no alcanza</a:t>
             </a:r>
           </a:p>
         </p:txBody>
@@ -6699,7 +6732,7 @@
                 </a:solidFill>
                 <a:latin typeface="Calibri"/>
               </a:rPr>
-              <a:t>Sesión 9 · Móvil y Regresión Visual · Slide 22</a:t>
+              <a:t>Sesión 9 · Móvil y Regresión Visual · Slide 21</a:t>
             </a:r>
           </a:p>
         </p:txBody>
@@ -6738,71 +6771,55 @@
                 </a:solidFill>
                 <a:latin typeface="Calibri"/>
               </a:rPr>
-              <a:t>• Distingo web móvil, híbrido y nativo</a:t>
-            </a:r>
-          </a:p>
-          <a:p>
-            <a:pPr>
-              <a:spcAft>
-                <a:spcPts val="1000"/>
-              </a:spcAft>
-            </a:pPr>
-            <a:r>
-              <a:rPr sz="1800" b="0">
-                <a:solidFill>
-                  <a:srgbClr val="2C3E50"/>
-                </a:solidFill>
-                <a:latin typeface="Calibri"/>
-              </a:rPr>
-              <a:t>• Ubico Appium, Maestro, Espresso, XCUITest, FlaUI/Pywinauto</a:t>
-            </a:r>
-          </a:p>
-          <a:p>
-            <a:pPr>
-              <a:spcAft>
-                <a:spcPts val="1000"/>
-              </a:spcAft>
-            </a:pPr>
-            <a:r>
-              <a:rPr sz="1800" b="0">
-                <a:solidFill>
-                  <a:srgbClr val="2C3E50"/>
-                </a:solidFill>
-                <a:latin typeface="Calibri"/>
-              </a:rPr>
-              <a:t>• Corrí smoke en viewport móvil + baselines visuales</a:t>
-            </a:r>
-          </a:p>
-          <a:p>
-            <a:pPr>
-              <a:spcAft>
-                <a:spcPts val="1000"/>
-              </a:spcAft>
-            </a:pPr>
-            <a:r>
-              <a:rPr sz="1800" b="0">
-                <a:solidFill>
-                  <a:srgbClr val="2C3E50"/>
-                </a:solidFill>
-                <a:latin typeface="Calibri"/>
-              </a:rPr>
-              <a:t>• Vi el gate fallar con UI rota</a:t>
-            </a:r>
-          </a:p>
-          <a:p>
-            <a:pPr>
-              <a:spcAft>
-                <a:spcPts val="1000"/>
-              </a:spcAft>
-            </a:pPr>
-            <a:r>
-              <a:rPr sz="1800" b="0">
-                <a:solidFill>
-                  <a:srgbClr val="2C3E50"/>
-                </a:solidFill>
-                <a:latin typeface="Calibri"/>
-              </a:rPr>
-              <a:t>• Sé cuándo mirar Applitools/Percy</a:t>
+              <a:t>• Applitools — IA visual, baselines cloud, caro y potente</a:t>
+            </a:r>
+          </a:p>
+          <a:p>
+            <a:pPr>
+              <a:spcAft>
+                <a:spcPts val="1000"/>
+              </a:spcAft>
+            </a:pPr>
+            <a:r>
+              <a:rPr sz="1800" b="0">
+                <a:solidFill>
+                  <a:srgbClr val="2C3E50"/>
+                </a:solidFill>
+                <a:latin typeface="Calibri"/>
+              </a:rPr>
+              <a:t>• Percy / Chromatic — revisiones visuales en el PR</a:t>
+            </a:r>
+          </a:p>
+          <a:p>
+            <a:pPr>
+              <a:spcAft>
+                <a:spcPts val="1000"/>
+              </a:spcAft>
+            </a:pPr>
+            <a:r>
+              <a:rPr sz="1800" b="0">
+                <a:solidFill>
+                  <a:srgbClr val="2C3E50"/>
+                </a:solidFill>
+                <a:latin typeface="Calibri"/>
+              </a:rPr>
+              <a:t>• PNG local: cero costo, control total, más mantenimiento manual</a:t>
+            </a:r>
+          </a:p>
+          <a:p>
+            <a:pPr>
+              <a:spcAft>
+                <a:spcPts val="1000"/>
+              </a:spcAft>
+            </a:pPr>
+            <a:r>
+              <a:rPr sz="1800" b="0">
+                <a:solidFill>
+                  <a:srgbClr val="2C3E50"/>
+                </a:solidFill>
+                <a:latin typeface="Calibri"/>
+              </a:rPr>
+              <a:t>• Regla: local para aprender; cloud cuando el equipo escala</a:t>
             </a:r>
           </a:p>
         </p:txBody>
@@ -6932,7 +6949,7 @@
                 </a:solidFill>
                 <a:latin typeface="Calibri"/>
               </a:rPr>
-              <a:t>No hagas esto</a:t>
+              <a:t>¿Te llevás esto?</a:t>
             </a:r>
           </a:p>
         </p:txBody>
@@ -6966,7 +6983,7 @@
                 </a:solidFill>
                 <a:latin typeface="Calibri"/>
               </a:rPr>
-              <a:t>Sesión 9 · Móvil y Regresión Visual · Slide 23</a:t>
+              <a:t>Sesión 9 · Móvil y Regresión Visual · Slide 22</a:t>
             </a:r>
           </a:p>
         </p:txBody>
@@ -7005,55 +7022,71 @@
                 </a:solidFill>
                 <a:latin typeface="Calibri"/>
               </a:rPr>
-              <a:t>• Regenerar baselines para “que pase” sin mirar el diff</a:t>
-            </a:r>
-          </a:p>
-          <a:p>
-            <a:pPr>
-              <a:spcAft>
-                <a:spcPts val="1000"/>
-              </a:spcAft>
-            </a:pPr>
-            <a:r>
-              <a:rPr sz="1800" b="0">
-                <a:solidFill>
-                  <a:srgbClr val="2C3E50"/>
-                </a:solidFill>
-                <a:latin typeface="Calibri"/>
-              </a:rPr>
-              <a:t>• Assert invertido (“espero que haya diff y paso”)</a:t>
-            </a:r>
-          </a:p>
-          <a:p>
-            <a:pPr>
-              <a:spcAft>
-                <a:spcPts val="1000"/>
-              </a:spcAft>
-            </a:pPr>
-            <a:r>
-              <a:rPr sz="1800" b="0">
-                <a:solidFill>
-                  <a:srgbClr val="2C3E50"/>
-                </a:solidFill>
-                <a:latin typeface="Calibri"/>
-              </a:rPr>
-              <a:t>• Solo probar desktop y llamar eso “cobertura móvil”</a:t>
-            </a:r>
-          </a:p>
-          <a:p>
-            <a:pPr>
-              <a:spcAft>
-                <a:spcPts val="1000"/>
-              </a:spcAft>
-            </a:pPr>
-            <a:r>
-              <a:rPr sz="1800" b="0">
-                <a:solidFill>
-                  <a:srgbClr val="2C3E50"/>
-                </a:solidFill>
-                <a:latin typeface="Calibri"/>
-              </a:rPr>
-              <a:t>• Instalar Appium el día del release sin granja lista</a:t>
+              <a:t>• Distingo web móvil, híbrido y nativo</a:t>
+            </a:r>
+          </a:p>
+          <a:p>
+            <a:pPr>
+              <a:spcAft>
+                <a:spcPts val="1000"/>
+              </a:spcAft>
+            </a:pPr>
+            <a:r>
+              <a:rPr sz="1800" b="0">
+                <a:solidFill>
+                  <a:srgbClr val="2C3E50"/>
+                </a:solidFill>
+                <a:latin typeface="Calibri"/>
+              </a:rPr>
+              <a:t>• Ubico Appium, Maestro, Espresso, XCUITest, FlaUI/Pywinauto</a:t>
+            </a:r>
+          </a:p>
+          <a:p>
+            <a:pPr>
+              <a:spcAft>
+                <a:spcPts val="1000"/>
+              </a:spcAft>
+            </a:pPr>
+            <a:r>
+              <a:rPr sz="1800" b="0">
+                <a:solidFill>
+                  <a:srgbClr val="2C3E50"/>
+                </a:solidFill>
+                <a:latin typeface="Calibri"/>
+              </a:rPr>
+              <a:t>• Corrí smoke en viewport móvil + baselines visuales</a:t>
+            </a:r>
+          </a:p>
+          <a:p>
+            <a:pPr>
+              <a:spcAft>
+                <a:spcPts val="1000"/>
+              </a:spcAft>
+            </a:pPr>
+            <a:r>
+              <a:rPr sz="1800" b="0">
+                <a:solidFill>
+                  <a:srgbClr val="2C3E50"/>
+                </a:solidFill>
+                <a:latin typeface="Calibri"/>
+              </a:rPr>
+              <a:t>• Vi el gate fallar con UI rota</a:t>
+            </a:r>
+          </a:p>
+          <a:p>
+            <a:pPr>
+              <a:spcAft>
+                <a:spcPts val="1000"/>
+              </a:spcAft>
+            </a:pPr>
+            <a:r>
+              <a:rPr sz="1800" b="0">
+                <a:solidFill>
+                  <a:srgbClr val="2C3E50"/>
+                </a:solidFill>
+                <a:latin typeface="Calibri"/>
+              </a:rPr>
+              <a:t>• Sé cuándo mirar Applitools/Percy</a:t>
             </a:r>
           </a:p>
         </p:txBody>
@@ -7102,6 +7135,257 @@
 </file>
 
 <file path=ppt/slides/slide24.xml><?xml version="1.0" encoding="utf-8"?>
+<p:sld xmlns:a="http://schemas.openxmlformats.org/drawingml/2006/main" xmlns:p="http://schemas.openxmlformats.org/presentationml/2006/main" xmlns:r="http://schemas.openxmlformats.org/officeDocument/2006/relationships">
+  <p:cSld>
+    <p:spTree>
+      <p:nvGrpSpPr>
+        <p:cNvPr id="1" name=""/>
+        <p:cNvGrpSpPr/>
+        <p:nvPr/>
+      </p:nvGrpSpPr>
+      <p:grpSpPr/>
+      <p:sp>
+        <p:nvSpPr>
+          <p:cNvPr id="2" name="Rectangle 1"/>
+          <p:cNvSpPr/>
+          <p:nvPr/>
+        </p:nvSpPr>
+        <p:spPr>
+          <a:xfrm>
+            <a:off x="0" y="0"/>
+            <a:ext cx="12191695" cy="146304"/>
+          </a:xfrm>
+          <a:prstGeom prst="rect">
+            <a:avLst/>
+          </a:prstGeom>
+          <a:solidFill>
+            <a:srgbClr val="0E7C7B"/>
+          </a:solidFill>
+          <a:ln>
+            <a:noFill/>
+          </a:ln>
+        </p:spPr>
+        <p:style>
+          <a:lnRef idx="1">
+            <a:schemeClr val="accent1"/>
+          </a:lnRef>
+          <a:fillRef idx="3">
+            <a:schemeClr val="accent1"/>
+          </a:fillRef>
+          <a:effectRef idx="2">
+            <a:schemeClr val="accent1"/>
+          </a:effectRef>
+          <a:fontRef idx="minor">
+            <a:schemeClr val="lt1"/>
+          </a:fontRef>
+        </p:style>
+        <p:txBody>
+          <a:bodyPr rtlCol="0" anchor="ctr"/>
+          <a:lstStyle/>
+          <a:p>
+            <a:pPr algn="ctr"/>
+          </a:p>
+        </p:txBody>
+      </p:sp>
+      <p:sp>
+        <p:nvSpPr>
+          <p:cNvPr id="3" name="TextBox 2"/>
+          <p:cNvSpPr txBox="1"/>
+          <p:nvPr/>
+        </p:nvSpPr>
+        <p:spPr>
+          <a:xfrm>
+            <a:off x="548640" y="320040"/>
+            <a:ext cx="11064240" cy="914400"/>
+          </a:xfrm>
+          <a:prstGeom prst="rect">
+            <a:avLst/>
+          </a:prstGeom>
+          <a:noFill/>
+        </p:spPr>
+        <p:txBody>
+          <a:bodyPr wrap="square">
+            <a:spAutoFit/>
+          </a:bodyPr>
+          <a:lstStyle/>
+          <a:p>
+            <a:r>
+              <a:rPr sz="2800" b="1">
+                <a:solidFill>
+                  <a:srgbClr val="1B2A4A"/>
+                </a:solidFill>
+                <a:latin typeface="Calibri"/>
+              </a:rPr>
+              <a:t>No hagas esto</a:t>
+            </a:r>
+          </a:p>
+        </p:txBody>
+      </p:sp>
+      <p:sp>
+        <p:nvSpPr>
+          <p:cNvPr id="4" name="TextBox 3"/>
+          <p:cNvSpPr txBox="1"/>
+          <p:nvPr/>
+        </p:nvSpPr>
+        <p:spPr>
+          <a:xfrm>
+            <a:off x="548640" y="1143000"/>
+            <a:ext cx="11064240" cy="274320"/>
+          </a:xfrm>
+          <a:prstGeom prst="rect">
+            <a:avLst/>
+          </a:prstGeom>
+          <a:noFill/>
+        </p:spPr>
+        <p:txBody>
+          <a:bodyPr wrap="none">
+            <a:spAutoFit/>
+          </a:bodyPr>
+          <a:lstStyle/>
+          <a:p>
+            <a:r>
+              <a:rPr sz="1200" b="0">
+                <a:solidFill>
+                  <a:srgbClr val="0E7C7B"/>
+                </a:solidFill>
+                <a:latin typeface="Calibri"/>
+              </a:rPr>
+              <a:t>Sesión 9 · Móvil y Regresión Visual · Slide 23</a:t>
+            </a:r>
+          </a:p>
+        </p:txBody>
+      </p:sp>
+      <p:sp>
+        <p:nvSpPr>
+          <p:cNvPr id="5" name="TextBox 4"/>
+          <p:cNvSpPr txBox="1"/>
+          <p:nvPr/>
+        </p:nvSpPr>
+        <p:spPr>
+          <a:xfrm>
+            <a:off x="640080" y="1554480"/>
+            <a:ext cx="10881360" cy="4754880"/>
+          </a:xfrm>
+          <a:prstGeom prst="rect">
+            <a:avLst/>
+          </a:prstGeom>
+          <a:noFill/>
+        </p:spPr>
+        <p:txBody>
+          <a:bodyPr wrap="square">
+            <a:spAutoFit/>
+          </a:bodyPr>
+          <a:lstStyle/>
+          <a:p>
+            <a:pPr>
+              <a:spcAft>
+                <a:spcPts val="1000"/>
+              </a:spcAft>
+            </a:pPr>
+            <a:r>
+              <a:rPr sz="1800" b="0">
+                <a:solidFill>
+                  <a:srgbClr val="2C3E50"/>
+                </a:solidFill>
+                <a:latin typeface="Calibri"/>
+              </a:rPr>
+              <a:t>• Regenerar baselines para “que pase” sin mirar el diff</a:t>
+            </a:r>
+          </a:p>
+          <a:p>
+            <a:pPr>
+              <a:spcAft>
+                <a:spcPts val="1000"/>
+              </a:spcAft>
+            </a:pPr>
+            <a:r>
+              <a:rPr sz="1800" b="0">
+                <a:solidFill>
+                  <a:srgbClr val="2C3E50"/>
+                </a:solidFill>
+                <a:latin typeface="Calibri"/>
+              </a:rPr>
+              <a:t>• Assert invertido (“espero que haya diff y paso”)</a:t>
+            </a:r>
+          </a:p>
+          <a:p>
+            <a:pPr>
+              <a:spcAft>
+                <a:spcPts val="1000"/>
+              </a:spcAft>
+            </a:pPr>
+            <a:r>
+              <a:rPr sz="1800" b="0">
+                <a:solidFill>
+                  <a:srgbClr val="2C3E50"/>
+                </a:solidFill>
+                <a:latin typeface="Calibri"/>
+              </a:rPr>
+              <a:t>• Solo probar desktop y llamar eso “cobertura móvil”</a:t>
+            </a:r>
+          </a:p>
+          <a:p>
+            <a:pPr>
+              <a:spcAft>
+                <a:spcPts val="1000"/>
+              </a:spcAft>
+            </a:pPr>
+            <a:r>
+              <a:rPr sz="1800" b="0">
+                <a:solidFill>
+                  <a:srgbClr val="2C3E50"/>
+                </a:solidFill>
+                <a:latin typeface="Calibri"/>
+              </a:rPr>
+              <a:t>• Instalar Appium el día del release sin granja lista</a:t>
+            </a:r>
+          </a:p>
+        </p:txBody>
+      </p:sp>
+      <p:sp>
+        <p:nvSpPr>
+          <p:cNvPr id="6" name="TextBox 5"/>
+          <p:cNvSpPr txBox="1"/>
+          <p:nvPr/>
+        </p:nvSpPr>
+        <p:spPr>
+          <a:xfrm>
+            <a:off x="548640" y="6446520"/>
+            <a:ext cx="11064240" cy="274320"/>
+          </a:xfrm>
+          <a:prstGeom prst="rect">
+            <a:avLst/>
+          </a:prstGeom>
+          <a:noFill/>
+        </p:spPr>
+        <p:txBody>
+          <a:bodyPr wrap="none">
+            <a:spAutoFit/>
+          </a:bodyPr>
+          <a:lstStyle/>
+          <a:p>
+            <a:pPr algn="r"/>
+            <a:r>
+              <a:rPr sz="1000" b="0">
+                <a:solidFill>
+                  <a:srgbClr val="7F8C8D"/>
+                </a:solidFill>
+                <a:latin typeface="Calibri"/>
+              </a:rPr>
+              <a:t>Certificación 3 — APIs, Performance y Seguridad</a:t>
+            </a:r>
+          </a:p>
+        </p:txBody>
+      </p:sp>
+    </p:spTree>
+  </p:cSld>
+  <p:clrMapOvr>
+    <a:masterClrMapping/>
+  </p:clrMapOvr>
+</p:sld>
+</file>
+
+<file path=ppt/slides/slide25.xml><?xml version="1.0" encoding="utf-8"?>
 <p:sld xmlns:a="http://schemas.openxmlformats.org/drawingml/2006/main" xmlns:p="http://schemas.openxmlformats.org/presentationml/2006/main" xmlns:r="http://schemas.openxmlformats.org/officeDocument/2006/relationships">
   <p:cSld>
     <p:spTree>

</xml_diff>